<commit_message>
feat(model): add credit scorecard review
</commit_message>
<xml_diff>
--- a/summary.pptx
+++ b/summary.pptx
@@ -3552,7 +3552,15 @@
               <a:defRPr sz="2000"/>
             </a:pPr>
             <a:r>
-              <a:t>Default rate uses resolved loans only; current loans censored/excluded.</a:t>
+              <a:t>Resolved-only model cohort; selection and censoring bias.</a:t>
+            </a:r>
+          </a:p>
+          <a:p>
+            <a:pPr>
+              <a:defRPr sz="2000"/>
+            </a:pPr>
+            <a:r>
+              <a:t>Rejected-applicant outcomes are unobserved; no reject inference.</a:t>
             </a:r>
           </a:p>
           <a:p>

</xml_diff>